<commit_message>
docs: apresentação enxuta com referências conferidas em ABNT (citações no texto e lista final)
Co-Authored-By: Claude Sonnet 5.5 <noreply@anthropic.com>
Claude-Session: https://claude.ai/code/session_01QBooVKGGKQGrenTtP2atqx
</commit_message>
<xml_diff>
--- a/docs/Apresentacao_SAREL_Enxuta_3_referencias_ABNT.pptx
+++ b/docs/Apresentacao_SAREL_Enxuta_3_referencias_ABNT.pptx
@@ -2902,7 +2902,7 @@
                 <a:ea typeface="Calibri" pitchFamily="34" charset="-122"/>
                 <a:cs typeface="Calibri" pitchFamily="34" charset="-120"/>
               </a:rPr>
-              <a:t>Alvo primário: fração da célula de 10 m delineada como erodida, de 0 a 1 </a:t>
+              <a:t>Alvo primário: fração da célula de 10 m delineada como erodida, de 0 a 1 (D26; ALTMAN; ROYSTON, 2006)</a:t>
             </a:r>
             <a:endParaRPr lang="en-US" sz="1300" dirty="0"/>
           </a:p>
@@ -2979,8 +2979,8 @@
         </p:nvSpPr>
         <p:spPr>
           <a:xfrm>
-            <a:off x="457200" y="4727448"/>
-            <a:ext cx="7863840" cy="365760"/>
+            <a:off x="457200" y="4709160"/>
+            <a:ext cx="7863840" cy="384048"/>
           </a:xfrm>
           <a:prstGeom prst="rect">
             <a:avLst/>
@@ -3004,7 +3004,7 @@
                 <a:ea typeface="Calibri" pitchFamily="34" charset="-122"/>
                 <a:cs typeface="Calibri" pitchFamily="34" charset="-120"/>
               </a:rPr>
-              <a:t>Fontes: SILVA (2026a, D02, D16 e D26).</a:t>
+              <a:t>Fontes: SILVA (2026a, D02, D16 e D26); Altman e Royston (2006).</a:t>
             </a:r>
             <a:endParaRPr lang="en-US" sz="1000" dirty="0"/>
           </a:p>
@@ -3460,7 +3460,7 @@
                 <a:ea typeface="Calibri" pitchFamily="34" charset="-122"/>
                 <a:cs typeface="Calibri" pitchFamily="34" charset="-120"/>
               </a:rPr>
-              <a:t>estimar a prevalência real e calibrar a posição; não é para treinar o modelo</a:t>
+              <a:t>estimar a prevalência real e calibrar a posição; não é para treinar o modelo (OLOFSSON et al., 2014)</a:t>
             </a:r>
             <a:endParaRPr lang="en-US" sz="1300" dirty="0"/>
           </a:p>
@@ -3550,8 +3550,8 @@
         </p:nvSpPr>
         <p:spPr>
           <a:xfrm>
-            <a:off x="457200" y="4727448"/>
-            <a:ext cx="7863840" cy="365760"/>
+            <a:off x="457200" y="4709160"/>
+            <a:ext cx="7863840" cy="384048"/>
           </a:xfrm>
           <a:prstGeom prst="rect">
             <a:avLst/>
@@ -3575,7 +3575,7 @@
                 <a:ea typeface="Calibri" pitchFamily="34" charset="-122"/>
                 <a:cs typeface="Calibri" pitchFamily="34" charset="-120"/>
               </a:rPr>
-              <a:t>Fontes: SILVA (2026a, D16 e D23).</a:t>
+              <a:t>Fontes: SILVA (2026a, D16 e D23); Olofsson et al. (2014).</a:t>
             </a:r>
             <a:endParaRPr lang="en-US" sz="1000" dirty="0"/>
           </a:p>
@@ -3980,29 +3980,7 @@
                 <a:ea typeface="Calibri" pitchFamily="34" charset="-122"/>
                 <a:cs typeface="Calibri" pitchFamily="34" charset="-120"/>
               </a:rPr>
-              <a:t>Distância ao ponto planejado (</a:t>
-            </a:r>
-            <a:r>
-              <a:rPr lang="en-US" sz="1050" dirty="0" err="1">
-                <a:solidFill>
-                  <a:srgbClr val="1B2A22"/>
-                </a:solidFill>
-                <a:latin typeface="Calibri" pitchFamily="34" charset="0"/>
-                <a:ea typeface="Calibri" pitchFamily="34" charset="-122"/>
-                <a:cs typeface="Calibri" pitchFamily="34" charset="-120"/>
-              </a:rPr>
-              <a:t>tolerância</a:t>
-            </a:r>
-            <a:r>
-              <a:rPr lang="en-US" sz="1050" dirty="0">
-                <a:solidFill>
-                  <a:srgbClr val="1B2A22"/>
-                </a:solidFill>
-                <a:latin typeface="Calibri" pitchFamily="34" charset="0"/>
-                <a:ea typeface="Calibri" pitchFamily="34" charset="-122"/>
-                <a:cs typeface="Calibri" pitchFamily="34" charset="-120"/>
-              </a:rPr>
-              <a:t>)</a:t>
+              <a:t>Distância ao ponto planejado (tolerância; CONGALTON; GREEN, 2019)</a:t>
             </a:r>
             <a:endParaRPr lang="en-US" sz="1050" dirty="0"/>
           </a:p>
@@ -4571,15 +4549,15 @@
               <a:buChar char="•"/>
             </a:pPr>
             <a:r>
-              <a:rPr lang="en-US" sz="1050" dirty="0">
-                <a:solidFill>
-                  <a:srgbClr val="1B2A22"/>
-                </a:solidFill>
-                <a:latin typeface="Calibri" pitchFamily="34" charset="0"/>
-                <a:ea typeface="Calibri" pitchFamily="34" charset="-122"/>
-                <a:cs typeface="Calibri" pitchFamily="34" charset="-120"/>
-              </a:rPr>
-              <a:t>Alimentam o fator P da RUSLE (RENARD et al., 1997; D22, provisório)</a:t>
+              <a:rPr lang="en-US" sz="900" dirty="0">
+                <a:solidFill>
+                  <a:srgbClr val="1B2A22"/>
+                </a:solidFill>
+                <a:latin typeface="Calibri" pitchFamily="34" charset="0"/>
+                <a:ea typeface="Calibri" pitchFamily="34" charset="-122"/>
+                <a:cs typeface="Calibri" pitchFamily="34" charset="-120"/>
+              </a:rPr>
+              <a:t>Alimentam o fator P da RUSLE (WISCHMEIER; SMITH, 1978; RENARD et al., 1997; D22, provisório)</a:t>
             </a:r>
             <a:endParaRPr lang="en-US" sz="1050" dirty="0"/>
           </a:p>
@@ -4744,8 +4722,8 @@
         </p:nvSpPr>
         <p:spPr>
           <a:xfrm>
-            <a:off x="457200" y="4663440"/>
-            <a:ext cx="7863840" cy="411480"/>
+            <a:off x="457200" y="4681728"/>
+            <a:ext cx="7863840" cy="457200"/>
           </a:xfrm>
           <a:prstGeom prst="rect">
             <a:avLst/>
@@ -4769,7 +4747,7 @@
                 <a:ea typeface="Calibri" pitchFamily="34" charset="-122"/>
                 <a:cs typeface="Calibri" pitchFamily="34" charset="-120"/>
               </a:rPr>
-              <a:t>Fontes: SILVA (2026a, D03, D22 e P03); exportação do SAREL Coletor e módulo de ingestão (SILVA, 2026c). Métricas de qualidade posicional são colunas acrescentadas ao final.</a:t>
+              <a:t>Fontes: SILVA (2026a, D03, D22 e P03); exportação do SAREL Coletor e módulo de ingestão (SILVA, 2026c); Wischmeier e Smith (1978); Renard et al. (1997); Congalton e Green (2019). Métricas de qualidade posicional são colunas acrescentadas ao final.</a:t>
             </a:r>
             <a:endParaRPr lang="en-US" sz="950" dirty="0"/>
           </a:p>
@@ -5010,7 +4988,7 @@
                 <a:ea typeface="Calibri" pitchFamily="34" charset="-122"/>
                 <a:cs typeface="Calibri" pitchFamily="34" charset="-120"/>
               </a:rPr>
-              <a:t>Desenho amostral e critério de avaliação pré-registrados</a:t>
+              <a:t>Desenho amostral e critério de avaliação pré-registrados (NOSEK et al., 2018)</a:t>
             </a:r>
             <a:endParaRPr lang="en-US" sz="1250" dirty="0"/>
           </a:p>
@@ -5218,8 +5196,8 @@
         </p:nvSpPr>
         <p:spPr>
           <a:xfrm>
-            <a:off x="457200" y="4727448"/>
-            <a:ext cx="7863840" cy="365760"/>
+            <a:off x="457200" y="4709160"/>
+            <a:ext cx="7863840" cy="384048"/>
           </a:xfrm>
           <a:prstGeom prst="rect">
             <a:avLst/>
@@ -5243,7 +5221,7 @@
                 <a:ea typeface="Calibri" pitchFamily="34" charset="-122"/>
                 <a:cs typeface="Calibri" pitchFamily="34" charset="-120"/>
               </a:rPr>
-              <a:t>Fontes: SILVA (2026a, 2026b).</a:t>
+              <a:t>Fontes: SILVA (2026a, 2026b); Nosek et al. (2018).</a:t>
             </a:r>
             <a:endParaRPr lang="en-US" sz="1000" dirty="0"/>
           </a:p>
@@ -5368,8 +5346,8 @@
         </p:nvSpPr>
         <p:spPr>
           <a:xfrm>
-            <a:off x="457200" y="1005840"/>
-            <a:ext cx="8229600" cy="3566160"/>
+            <a:off x="365760" y="868680"/>
+            <a:ext cx="4206240" cy="3840480"/>
           </a:xfrm>
           <a:prstGeom prst="rect">
             <a:avLst/>
@@ -5383,180 +5361,496 @@
           <a:p>
             <a:pPr marL="0" indent="0">
               <a:spcAft>
-                <a:spcPts val="500"/>
+                <a:spcPts val="300"/>
               </a:spcAft>
               <a:buNone/>
             </a:pPr>
             <a:r>
-              <a:rPr lang="en-US" sz="1050" dirty="0" i="0" b="0">
-                <a:solidFill>
-                  <a:srgbClr val="1B2A22"/>
-                </a:solidFill>
-                <a:latin typeface="Calibri" pitchFamily="34" charset="0"/>
-                <a:ea typeface="Calibri" pitchFamily="34" charset="-122"/>
-                <a:cs typeface="Calibri" pitchFamily="34" charset="-120"/>
-              </a:rPr>
-              <a:t>COELHO, M. R. et al. </a:t>
+              <a:rPr lang="en-US" sz="850" dirty="0" i="0" b="0">
+                <a:solidFill>
+                  <a:srgbClr val="1B2A22"/>
+                </a:solidFill>
+                <a:latin typeface="Calibri" pitchFamily="34" charset="0"/>
+                <a:ea typeface="Calibri" pitchFamily="34" charset="-122"/>
+                <a:cs typeface="Calibri" pitchFamily="34" charset="-120"/>
+              </a:rPr>
+              <a:t>ALTMAN, D. G.; ROYSTON, P. </a:t>
             </a:r>
             <a:endParaRPr lang="en-US" sz="1050" dirty="0"/>
             <a:r>
-              <a:rPr lang="en-US" sz="1050" dirty="0" i="0" b="1">
-                <a:solidFill>
-                  <a:srgbClr val="1B2A22"/>
-                </a:solidFill>
-                <a:latin typeface="Calibri" pitchFamily="34" charset="0"/>
-                <a:ea typeface="Calibri" pitchFamily="34" charset="-122"/>
-                <a:cs typeface="Calibri" pitchFamily="34" charset="-120"/>
-              </a:rPr>
-              <a:t>Erodibilidade dos solos do Brasil</a:t>
-            </a:r>
-            <a:r>
-              <a:rPr lang="en-US" sz="1050" dirty="0" i="0" b="0">
-                <a:solidFill>
-                  <a:srgbClr val="1B2A22"/>
-                </a:solidFill>
-                <a:latin typeface="Calibri" pitchFamily="34" charset="0"/>
-                <a:ea typeface="Calibri" pitchFamily="34" charset="-122"/>
-                <a:cs typeface="Calibri" pitchFamily="34" charset="-120"/>
-              </a:rPr>
-              <a:t>. Rio de Janeiro: Embrapa Solos, 2024. 40 p. (Documentos, 246). ISSN 1517-2627.</a:t>
+              <a:rPr lang="en-US" sz="850" dirty="0" i="0" b="1">
+                <a:solidFill>
+                  <a:srgbClr val="1B2A22"/>
+                </a:solidFill>
+                <a:latin typeface="Calibri" pitchFamily="34" charset="0"/>
+                <a:ea typeface="Calibri" pitchFamily="34" charset="-122"/>
+                <a:cs typeface="Calibri" pitchFamily="34" charset="-120"/>
+              </a:rPr>
+              <a:t>The cost of dichotomising continuous variables</a:t>
+            </a:r>
+            <a:r>
+              <a:rPr lang="en-US" sz="850" dirty="0" i="0" b="0">
+                <a:solidFill>
+                  <a:srgbClr val="1B2A22"/>
+                </a:solidFill>
+                <a:latin typeface="Calibri" pitchFamily="34" charset="0"/>
+                <a:ea typeface="Calibri" pitchFamily="34" charset="-122"/>
+                <a:cs typeface="Calibri" pitchFamily="34" charset="-120"/>
+              </a:rPr>
+              <a:t>. BMJ, v. 332, n. 7549, p. 1080, 2006. DOI 10.1136/bmj.332.7549.1080.</a:t>
             </a:r>
           </a:p>
           <a:p>
             <a:pPr marL="0" indent="0">
               <a:spcAft>
-                <a:spcPts val="500"/>
+                <a:spcPts val="300"/>
               </a:spcAft>
               <a:buNone/>
             </a:pPr>
             <a:r>
-              <a:rPr lang="en-US" sz="1050" dirty="0" i="0" b="0">
-                <a:solidFill>
-                  <a:srgbClr val="1B2A22"/>
-                </a:solidFill>
-                <a:latin typeface="Calibri" pitchFamily="34" charset="0"/>
-                <a:ea typeface="Calibri" pitchFamily="34" charset="-122"/>
-                <a:cs typeface="Calibri" pitchFamily="34" charset="-120"/>
-              </a:rPr>
-              <a:t>RENARD, K. G.; FOSTER, G. R.; WEESIES, G. A.; McCOOL, D. K.; YODER, D. C. </a:t>
+              <a:rPr lang="en-US" sz="850" dirty="0" i="0" b="0">
+                <a:solidFill>
+                  <a:srgbClr val="1B2A22"/>
+                </a:solidFill>
+                <a:latin typeface="Calibri" pitchFamily="34" charset="0"/>
+                <a:ea typeface="Calibri" pitchFamily="34" charset="-122"/>
+                <a:cs typeface="Calibri" pitchFamily="34" charset="-120"/>
+              </a:rPr>
+              <a:t>COCHRAN, W. G. </a:t>
             </a:r>
             <a:endParaRPr lang="en-US" sz="1050" dirty="0"/>
             <a:r>
-              <a:rPr lang="en-US" sz="1050" dirty="0" i="0" b="1">
-                <a:solidFill>
-                  <a:srgbClr val="1B2A22"/>
-                </a:solidFill>
-                <a:latin typeface="Calibri" pitchFamily="34" charset="0"/>
-                <a:ea typeface="Calibri" pitchFamily="34" charset="-122"/>
-                <a:cs typeface="Calibri" pitchFamily="34" charset="-120"/>
-              </a:rPr>
-              <a:t>Predicting soil erosion by water</a:t>
-            </a:r>
-            <a:r>
-              <a:rPr lang="en-US" sz="1050" dirty="0" i="0" b="0">
-                <a:solidFill>
-                  <a:srgbClr val="1B2A22"/>
-                </a:solidFill>
-                <a:latin typeface="Calibri" pitchFamily="34" charset="0"/>
-                <a:ea typeface="Calibri" pitchFamily="34" charset="-122"/>
-                <a:cs typeface="Calibri" pitchFamily="34" charset="-120"/>
-              </a:rPr>
-              <a:t>: a guide to conservation planning with the Revised Universal Soil Loss Equation (RUSLE). [S. l.]: United States Department of Agriculture, 1997. 404 p. (Agriculture Handbook, 703).</a:t>
+              <a:rPr lang="en-US" sz="850" dirty="0" i="0" b="1">
+                <a:solidFill>
+                  <a:srgbClr val="1B2A22"/>
+                </a:solidFill>
+                <a:latin typeface="Calibri" pitchFamily="34" charset="0"/>
+                <a:ea typeface="Calibri" pitchFamily="34" charset="-122"/>
+                <a:cs typeface="Calibri" pitchFamily="34" charset="-120"/>
+              </a:rPr>
+              <a:t>Sampling techniques</a:t>
+            </a:r>
+            <a:r>
+              <a:rPr lang="en-US" sz="850" dirty="0" i="0" b="0">
+                <a:solidFill>
+                  <a:srgbClr val="1B2A22"/>
+                </a:solidFill>
+                <a:latin typeface="Calibri" pitchFamily="34" charset="0"/>
+                <a:ea typeface="Calibri" pitchFamily="34" charset="-122"/>
+                <a:cs typeface="Calibri" pitchFamily="34" charset="-120"/>
+              </a:rPr>
+              <a:t>. 3. ed. New York: John Wiley &amp; Sons, 1977. 428 p.</a:t>
             </a:r>
           </a:p>
           <a:p>
             <a:pPr marL="0" indent="0">
               <a:spcAft>
-                <a:spcPts val="500"/>
+                <a:spcPts val="300"/>
               </a:spcAft>
               <a:buNone/>
             </a:pPr>
             <a:r>
-              <a:rPr lang="en-US" sz="1050" dirty="0" i="0" b="0">
-                <a:solidFill>
-                  <a:srgbClr val="1B2A22"/>
-                </a:solidFill>
-                <a:latin typeface="Calibri" pitchFamily="34" charset="0"/>
-                <a:ea typeface="Calibri" pitchFamily="34" charset="-122"/>
-                <a:cs typeface="Calibri" pitchFamily="34" charset="-120"/>
-              </a:rPr>
-              <a:t>SILVA, L. A. F. da. </a:t>
+              <a:rPr lang="en-US" sz="850" dirty="0" i="0" b="0">
+                <a:solidFill>
+                  <a:srgbClr val="1B2A22"/>
+                </a:solidFill>
+                <a:latin typeface="Calibri" pitchFamily="34" charset="0"/>
+                <a:ea typeface="Calibri" pitchFamily="34" charset="-122"/>
+                <a:cs typeface="Calibri" pitchFamily="34" charset="-120"/>
+              </a:rPr>
+              <a:t>COELHO, M. R. et al. </a:t>
             </a:r>
             <a:endParaRPr lang="en-US" sz="1050" dirty="0"/>
             <a:r>
-              <a:rPr lang="en-US" sz="1050" dirty="0" i="0" b="1">
-                <a:solidFill>
-                  <a:srgbClr val="1B2A22"/>
-                </a:solidFill>
-                <a:latin typeface="Calibri" pitchFamily="34" charset="0"/>
-                <a:ea typeface="Calibri" pitchFamily="34" charset="-122"/>
-                <a:cs typeface="Calibri" pitchFamily="34" charset="-120"/>
-              </a:rPr>
-              <a:t>Registro de decisões metodológicas do SAREL v2</a:t>
-            </a:r>
-            <a:r>
-              <a:rPr lang="en-US" sz="1050" dirty="0" i="0" b="0">
-                <a:solidFill>
-                  <a:srgbClr val="1B2A22"/>
-                </a:solidFill>
-                <a:latin typeface="Calibri" pitchFamily="34" charset="0"/>
-                <a:ea typeface="Calibri" pitchFamily="34" charset="-122"/>
-                <a:cs typeface="Calibri" pitchFamily="34" charset="-120"/>
-              </a:rPr>
-              <a:t>: decisões D01 a D26 e parâmetros P01 a P24. Medianeira: UTFPR, 2026a. Documento eletrônico (DECISOES.md), gerado em 16 out. 2026. Não publicado.</a:t>
+              <a:rPr lang="en-US" sz="850" dirty="0" i="0" b="1">
+                <a:solidFill>
+                  <a:srgbClr val="1B2A22"/>
+                </a:solidFill>
+                <a:latin typeface="Calibri" pitchFamily="34" charset="0"/>
+                <a:ea typeface="Calibri" pitchFamily="34" charset="-122"/>
+                <a:cs typeface="Calibri" pitchFamily="34" charset="-120"/>
+              </a:rPr>
+              <a:t>Erodibilidade dos solos do Brasil</a:t>
+            </a:r>
+            <a:r>
+              <a:rPr lang="en-US" sz="850" dirty="0" i="0" b="0">
+                <a:solidFill>
+                  <a:srgbClr val="1B2A22"/>
+                </a:solidFill>
+                <a:latin typeface="Calibri" pitchFamily="34" charset="0"/>
+                <a:ea typeface="Calibri" pitchFamily="34" charset="-122"/>
+                <a:cs typeface="Calibri" pitchFamily="34" charset="-120"/>
+              </a:rPr>
+              <a:t>. Rio de Janeiro: Embrapa Solos, 2024. 40 p. (Documentos, 246).</a:t>
             </a:r>
           </a:p>
           <a:p>
             <a:pPr marL="0" indent="0">
               <a:spcAft>
-                <a:spcPts val="500"/>
+                <a:spcPts val="300"/>
               </a:spcAft>
               <a:buNone/>
             </a:pPr>
             <a:r>
-              <a:rPr lang="en-US" sz="1050" dirty="0" i="0" b="0">
-                <a:solidFill>
-                  <a:srgbClr val="1B2A22"/>
-                </a:solidFill>
-                <a:latin typeface="Calibri" pitchFamily="34" charset="0"/>
-                <a:ea typeface="Calibri" pitchFamily="34" charset="-122"/>
-                <a:cs typeface="Calibri" pitchFamily="34" charset="-120"/>
-              </a:rPr>
-              <a:t>SILVA, L. A. F. da. </a:t>
+              <a:rPr lang="en-US" sz="850" dirty="0" i="0" b="0">
+                <a:solidFill>
+                  <a:srgbClr val="1B2A22"/>
+                </a:solidFill>
+                <a:latin typeface="Calibri" pitchFamily="34" charset="0"/>
+                <a:ea typeface="Calibri" pitchFamily="34" charset="-122"/>
+                <a:cs typeface="Calibri" pitchFamily="34" charset="-120"/>
+              </a:rPr>
+              <a:t>CONGALTON, R. G.; GREEN, K. </a:t>
             </a:r>
             <a:endParaRPr lang="en-US" sz="1050" dirty="0"/>
             <a:r>
-              <a:rPr lang="en-US" sz="1050" dirty="0" i="0" b="1">
-                <a:solidFill>
-                  <a:srgbClr val="1B2A22"/>
-                </a:solidFill>
-                <a:latin typeface="Calibri" pitchFamily="34" charset="0"/>
-                <a:ea typeface="Calibri" pitchFamily="34" charset="-122"/>
-                <a:cs typeface="Calibri" pitchFamily="34" charset="-120"/>
-              </a:rPr>
-              <a:t>Verificações metodológicas do SAREL v2</a:t>
-            </a:r>
-            <a:r>
-              <a:rPr lang="en-US" sz="1050" dirty="0" i="0" b="0">
-                <a:solidFill>
-                  <a:srgbClr val="1B2A22"/>
-                </a:solidFill>
-                <a:latin typeface="Calibri" pitchFamily="34" charset="0"/>
-                <a:ea typeface="Calibri" pitchFamily="34" charset="-122"/>
-                <a:cs typeface="Calibri" pitchFamily="34" charset="-120"/>
-              </a:rPr>
-              <a:t>: levantamento fundiário e gargalo dos estratos (29 set. 2026); remedição dos candidatos da BP3 (30 set. 2026); cobertura dos voos (27 set. 2026). Medianeira: UTFPR, 2026b. Documentos eletrônicos. Não publicado.</a:t>
+              <a:rPr lang="en-US" sz="850" dirty="0" i="0" b="1">
+                <a:solidFill>
+                  <a:srgbClr val="1B2A22"/>
+                </a:solidFill>
+                <a:latin typeface="Calibri" pitchFamily="34" charset="0"/>
+                <a:ea typeface="Calibri" pitchFamily="34" charset="-122"/>
+                <a:cs typeface="Calibri" pitchFamily="34" charset="-120"/>
+              </a:rPr>
+              <a:t>Assessing the accuracy of remotely sensed data</a:t>
+            </a:r>
+            <a:r>
+              <a:rPr lang="en-US" sz="850" dirty="0" i="0" b="0">
+                <a:solidFill>
+                  <a:srgbClr val="1B2A22"/>
+                </a:solidFill>
+                <a:latin typeface="Calibri" pitchFamily="34" charset="0"/>
+                <a:ea typeface="Calibri" pitchFamily="34" charset="-122"/>
+                <a:cs typeface="Calibri" pitchFamily="34" charset="-120"/>
+              </a:rPr>
+              <a:t>: principles and practices. 3. ed. [S. l.]: CRC Press, 2019.</a:t>
             </a:r>
           </a:p>
           <a:p>
             <a:pPr marL="0" indent="0">
               <a:spcAft>
-                <a:spcPts val="500"/>
+                <a:spcPts val="300"/>
               </a:spcAft>
               <a:buNone/>
             </a:pPr>
             <a:r>
-              <a:rPr lang="en-US" sz="1050" dirty="0" i="0" b="0">
+              <a:rPr lang="en-US" sz="850" dirty="0" i="0" b="0">
+                <a:solidFill>
+                  <a:srgbClr val="1B2A22"/>
+                </a:solidFill>
+                <a:latin typeface="Calibri" pitchFamily="34" charset="0"/>
+                <a:ea typeface="Calibri" pitchFamily="34" charset="-122"/>
+                <a:cs typeface="Calibri" pitchFamily="34" charset="-120"/>
+              </a:rPr>
+              <a:t>DRUSCH, M. et al. Sentinel-2: ESA's optical high-resolution mission for GMES operational services. </a:t>
+            </a:r>
+            <a:endParaRPr lang="en-US" sz="1050" dirty="0"/>
+            <a:r>
+              <a:rPr lang="en-US" sz="850" dirty="0" i="0" b="1">
+                <a:solidFill>
+                  <a:srgbClr val="1B2A22"/>
+                </a:solidFill>
+                <a:latin typeface="Calibri" pitchFamily="34" charset="0"/>
+                <a:ea typeface="Calibri" pitchFamily="34" charset="-122"/>
+                <a:cs typeface="Calibri" pitchFamily="34" charset="-120"/>
+              </a:rPr>
+              <a:t>Remote Sensing of Environment</a:t>
+            </a:r>
+            <a:r>
+              <a:rPr lang="en-US" sz="850" dirty="0" i="0" b="0">
+                <a:solidFill>
+                  <a:srgbClr val="1B2A22"/>
+                </a:solidFill>
+                <a:latin typeface="Calibri" pitchFamily="34" charset="0"/>
+                <a:ea typeface="Calibri" pitchFamily="34" charset="-122"/>
+                <a:cs typeface="Calibri" pitchFamily="34" charset="-120"/>
+              </a:rPr>
+              <a:t>, v. 120, p. 25-36, 2012.</a:t>
+            </a:r>
+          </a:p>
+          <a:p>
+            <a:pPr marL="0" indent="0">
+              <a:spcAft>
+                <a:spcPts val="300"/>
+              </a:spcAft>
+              <a:buNone/>
+            </a:pPr>
+            <a:r>
+              <a:rPr lang="en-US" sz="850" dirty="0" i="0" b="0">
+                <a:solidFill>
+                  <a:srgbClr val="1B2A22"/>
+                </a:solidFill>
+                <a:latin typeface="Calibri" pitchFamily="34" charset="0"/>
+                <a:ea typeface="Calibri" pitchFamily="34" charset="-122"/>
+                <a:cs typeface="Calibri" pitchFamily="34" charset="-120"/>
+              </a:rPr>
+              <a:t>GORELICK, N. et al. Google Earth Engine: planetary-scale geospatial analysis for everyone. </a:t>
+            </a:r>
+            <a:endParaRPr lang="en-US" sz="1050" dirty="0"/>
+            <a:r>
+              <a:rPr lang="en-US" sz="850" dirty="0" i="0" b="1">
+                <a:solidFill>
+                  <a:srgbClr val="1B2A22"/>
+                </a:solidFill>
+                <a:latin typeface="Calibri" pitchFamily="34" charset="0"/>
+                <a:ea typeface="Calibri" pitchFamily="34" charset="-122"/>
+                <a:cs typeface="Calibri" pitchFamily="34" charset="-120"/>
+              </a:rPr>
+              <a:t>Remote Sensing of Environment</a:t>
+            </a:r>
+            <a:r>
+              <a:rPr lang="en-US" sz="850" dirty="0" i="0" b="0">
+                <a:solidFill>
+                  <a:srgbClr val="1B2A22"/>
+                </a:solidFill>
+                <a:latin typeface="Calibri" pitchFamily="34" charset="0"/>
+                <a:ea typeface="Calibri" pitchFamily="34" charset="-122"/>
+                <a:cs typeface="Calibri" pitchFamily="34" charset="-120"/>
+              </a:rPr>
+              <a:t>, v. 202, p. 18-27, 2017. DOI 10.1016/j.rse.2017.06.031.</a:t>
+            </a:r>
+          </a:p>
+          <a:p>
+            <a:pPr marL="0" indent="0">
+              <a:spcAft>
+                <a:spcPts val="300"/>
+              </a:spcAft>
+              <a:buNone/>
+            </a:pPr>
+            <a:r>
+              <a:rPr lang="en-US" sz="850" dirty="0" i="0" b="0">
+                <a:solidFill>
+                  <a:srgbClr val="1B2A22"/>
+                </a:solidFill>
+                <a:latin typeface="Calibri" pitchFamily="34" charset="0"/>
+                <a:ea typeface="Calibri" pitchFamily="34" charset="-122"/>
+                <a:cs typeface="Calibri" pitchFamily="34" charset="-120"/>
+              </a:rPr>
+              <a:t>KING, G.; ZENG, L. Logistic regression in rare events data. </a:t>
+            </a:r>
+            <a:endParaRPr lang="en-US" sz="1050" dirty="0"/>
+            <a:r>
+              <a:rPr lang="en-US" sz="850" dirty="0" i="0" b="1">
+                <a:solidFill>
+                  <a:srgbClr val="1B2A22"/>
+                </a:solidFill>
+                <a:latin typeface="Calibri" pitchFamily="34" charset="0"/>
+                <a:ea typeface="Calibri" pitchFamily="34" charset="-122"/>
+                <a:cs typeface="Calibri" pitchFamily="34" charset="-120"/>
+              </a:rPr>
+              <a:t>Political Analysis</a:t>
+            </a:r>
+            <a:r>
+              <a:rPr lang="en-US" sz="850" dirty="0" i="0" b="0">
+                <a:solidFill>
+                  <a:srgbClr val="1B2A22"/>
+                </a:solidFill>
+                <a:latin typeface="Calibri" pitchFamily="34" charset="0"/>
+                <a:ea typeface="Calibri" pitchFamily="34" charset="-122"/>
+                <a:cs typeface="Calibri" pitchFamily="34" charset="-120"/>
+              </a:rPr>
+              <a:t>, v. 9, n. 2, p. 137-163, 2001.</a:t>
+            </a:r>
+          </a:p>
+          <a:p>
+            <a:pPr marL="0" indent="0">
+              <a:spcAft>
+                <a:spcPts val="300"/>
+              </a:spcAft>
+              <a:buNone/>
+            </a:pPr>
+            <a:r>
+              <a:rPr lang="en-US" sz="850" dirty="0" i="0" b="0">
+                <a:solidFill>
+                  <a:srgbClr val="1B2A22"/>
+                </a:solidFill>
+                <a:latin typeface="Calibri" pitchFamily="34" charset="0"/>
+                <a:ea typeface="Calibri" pitchFamily="34" charset="-122"/>
+                <a:cs typeface="Calibri" pitchFamily="34" charset="-120"/>
+              </a:rPr>
+              <a:t>NOSEK, B. A. et al. The preregistration revolution. </a:t>
+            </a:r>
+            <a:endParaRPr lang="en-US" sz="1050" dirty="0"/>
+            <a:r>
+              <a:rPr lang="en-US" sz="850" dirty="0" i="0" b="1">
+                <a:solidFill>
+                  <a:srgbClr val="1B2A22"/>
+                </a:solidFill>
+                <a:latin typeface="Calibri" pitchFamily="34" charset="0"/>
+                <a:ea typeface="Calibri" pitchFamily="34" charset="-122"/>
+                <a:cs typeface="Calibri" pitchFamily="34" charset="-120"/>
+              </a:rPr>
+              <a:t>Proceedings of the National Academy of Sciences</a:t>
+            </a:r>
+            <a:r>
+              <a:rPr lang="en-US" sz="850" dirty="0" i="0" b="0">
+                <a:solidFill>
+                  <a:srgbClr val="1B2A22"/>
+                </a:solidFill>
+                <a:latin typeface="Calibri" pitchFamily="34" charset="0"/>
+                <a:ea typeface="Calibri" pitchFamily="34" charset="-122"/>
+                <a:cs typeface="Calibri" pitchFamily="34" charset="-120"/>
+              </a:rPr>
+              <a:t>, v. 115, n. 11, p. 2600-2606, 2018. DOI 10.1073/pnas.1708274114.</a:t>
+            </a:r>
+          </a:p>
+          <a:p>
+            <a:pPr marL="0" indent="0">
+              <a:spcAft>
+                <a:spcPts val="300"/>
+              </a:spcAft>
+              <a:buNone/>
+            </a:pPr>
+            <a:r>
+              <a:rPr lang="en-US" sz="850" dirty="0" i="0" b="0">
+                <a:solidFill>
+                  <a:srgbClr val="1B2A22"/>
+                </a:solidFill>
+                <a:latin typeface="Calibri" pitchFamily="34" charset="0"/>
+                <a:ea typeface="Calibri" pitchFamily="34" charset="-122"/>
+                <a:cs typeface="Calibri" pitchFamily="34" charset="-120"/>
+              </a:rPr>
+              <a:t>OLOFSSON, P. et al. Good practices for estimating area and assessing accuracy of land change. </a:t>
+            </a:r>
+            <a:endParaRPr lang="en-US" sz="1050" dirty="0"/>
+            <a:r>
+              <a:rPr lang="en-US" sz="850" dirty="0" i="0" b="1">
+                <a:solidFill>
+                  <a:srgbClr val="1B2A22"/>
+                </a:solidFill>
+                <a:latin typeface="Calibri" pitchFamily="34" charset="0"/>
+                <a:ea typeface="Calibri" pitchFamily="34" charset="-122"/>
+                <a:cs typeface="Calibri" pitchFamily="34" charset="-120"/>
+              </a:rPr>
+              <a:t>Remote Sensing of Environment</a:t>
+            </a:r>
+            <a:r>
+              <a:rPr lang="en-US" sz="850" dirty="0" i="0" b="0">
+                <a:solidFill>
+                  <a:srgbClr val="1B2A22"/>
+                </a:solidFill>
+                <a:latin typeface="Calibri" pitchFamily="34" charset="0"/>
+                <a:ea typeface="Calibri" pitchFamily="34" charset="-122"/>
+                <a:cs typeface="Calibri" pitchFamily="34" charset="-120"/>
+              </a:rPr>
+              <a:t>, v. 148, p. 42-57, 2014.</a:t>
+            </a:r>
+          </a:p>
+        </p:txBody>
+      </p:sp>
+      <p:sp>
+        <p:nvSpPr>
+          <p:cNvPr id="6" name="Text 3"/>
+          <p:cNvSpPr txBox="1"/>
+          <p:nvPr/>
+        </p:nvSpPr>
+        <p:spPr>
+          <a:xfrm>
+            <a:off x="4663440" y="868680"/>
+            <a:ext cx="4114800" cy="3840480"/>
+          </a:xfrm>
+          <a:prstGeom prst="rect">
+            <a:avLst/>
+          </a:prstGeom>
+          <a:noFill/>
+          <a:ln/>
+        </p:spPr>
+        <p:txBody>
+          <a:bodyPr wrap="square" lIns="0" tIns="0" rIns="0" bIns="0" rtlCol="0" anchor="t"/>
+          <a:lstStyle/>
+          <a:p>
+            <a:pPr marL="0" indent="0">
+              <a:spcAft>
+                <a:spcPts val="300"/>
+              </a:spcAft>
+              <a:buNone/>
+            </a:pPr>
+            <a:r>
+              <a:rPr lang="en-US" sz="850" dirty="0" i="0" b="0">
+                <a:solidFill>
+                  <a:srgbClr val="1B2A22"/>
+                </a:solidFill>
+                <a:latin typeface="Calibri" pitchFamily="34" charset="0"/>
+                <a:ea typeface="Calibri" pitchFamily="34" charset="-122"/>
+                <a:cs typeface="Calibri" pitchFamily="34" charset="-120"/>
+              </a:rPr>
+              <a:t>PLOEG, T. van der; AUSTIN, P. C.; STEYERBERG, E. W. Modern modelling techniques are data hungry: a simulation study for predicting dichotomous endpoints. </a:t>
+            </a:r>
+            <a:endParaRPr lang="en-US" sz="1050" dirty="0"/>
+            <a:r>
+              <a:rPr lang="en-US" sz="850" dirty="0" i="0" b="1">
+                <a:solidFill>
+                  <a:srgbClr val="1B2A22"/>
+                </a:solidFill>
+                <a:latin typeface="Calibri" pitchFamily="34" charset="0"/>
+                <a:ea typeface="Calibri" pitchFamily="34" charset="-122"/>
+                <a:cs typeface="Calibri" pitchFamily="34" charset="-120"/>
+              </a:rPr>
+              <a:t>BMC Medical Research Methodology</a:t>
+            </a:r>
+            <a:r>
+              <a:rPr lang="en-US" sz="850" dirty="0" i="0" b="0">
+                <a:solidFill>
+                  <a:srgbClr val="1B2A22"/>
+                </a:solidFill>
+                <a:latin typeface="Calibri" pitchFamily="34" charset="0"/>
+                <a:ea typeface="Calibri" pitchFamily="34" charset="-122"/>
+                <a:cs typeface="Calibri" pitchFamily="34" charset="-120"/>
+              </a:rPr>
+              <a:t>, v. 14, art. 137, 2014. DOI 10.1186/1471-2288-14-137.</a:t>
+            </a:r>
+          </a:p>
+          <a:p>
+            <a:pPr marL="0" indent="0">
+              <a:spcAft>
+                <a:spcPts val="300"/>
+              </a:spcAft>
+              <a:buNone/>
+            </a:pPr>
+            <a:r>
+              <a:rPr lang="en-US" sz="850" dirty="0" i="0" b="0">
+                <a:solidFill>
+                  <a:srgbClr val="1B2A22"/>
+                </a:solidFill>
+                <a:latin typeface="Calibri" pitchFamily="34" charset="0"/>
+                <a:ea typeface="Calibri" pitchFamily="34" charset="-122"/>
+                <a:cs typeface="Calibri" pitchFamily="34" charset="-120"/>
+              </a:rPr>
+              <a:t>RENARD, K. G.; FOSTER, G. R.; WEESIES, G. A.; McCOOL, D. K.; YODER, D. C. </a:t>
+            </a:r>
+            <a:endParaRPr lang="en-US" sz="1050" dirty="0"/>
+            <a:r>
+              <a:rPr lang="en-US" sz="850" dirty="0" i="0" b="1">
+                <a:solidFill>
+                  <a:srgbClr val="1B2A22"/>
+                </a:solidFill>
+                <a:latin typeface="Calibri" pitchFamily="34" charset="0"/>
+                <a:ea typeface="Calibri" pitchFamily="34" charset="-122"/>
+                <a:cs typeface="Calibri" pitchFamily="34" charset="-120"/>
+              </a:rPr>
+              <a:t>Predicting soil erosion by water</a:t>
+            </a:r>
+            <a:r>
+              <a:rPr lang="en-US" sz="850" dirty="0" i="0" b="0">
+                <a:solidFill>
+                  <a:srgbClr val="1B2A22"/>
+                </a:solidFill>
+                <a:latin typeface="Calibri" pitchFamily="34" charset="0"/>
+                <a:ea typeface="Calibri" pitchFamily="34" charset="-122"/>
+                <a:cs typeface="Calibri" pitchFamily="34" charset="-120"/>
+              </a:rPr>
+              <a:t>: a guide to conservation planning with the Revised Universal Soil Loss Equation (RUSLE). [S. l.]: United States Department of Agriculture, 1997. 404 p. (Agriculture Handbook, 703).</a:t>
+            </a:r>
+          </a:p>
+          <a:p>
+            <a:pPr marL="0" indent="0">
+              <a:spcAft>
+                <a:spcPts val="300"/>
+              </a:spcAft>
+              <a:buNone/>
+            </a:pPr>
+            <a:r>
+              <a:rPr lang="en-US" sz="850" dirty="0" i="0" b="0">
                 <a:solidFill>
                   <a:srgbClr val="1B2A22"/>
                 </a:solidFill>
@@ -5568,7 +5862,91 @@
             </a:r>
             <a:endParaRPr lang="en-US" sz="1050" dirty="0"/>
             <a:r>
-              <a:rPr lang="en-US" sz="1050" dirty="0" i="0" b="1">
+              <a:rPr lang="en-US" sz="850" dirty="0" i="0" b="1">
+                <a:solidFill>
+                  <a:srgbClr val="1B2A22"/>
+                </a:solidFill>
+                <a:latin typeface="Calibri" pitchFamily="34" charset="0"/>
+                <a:ea typeface="Calibri" pitchFamily="34" charset="-122"/>
+                <a:cs typeface="Calibri" pitchFamily="34" charset="-120"/>
+              </a:rPr>
+              <a:t>Registro de decisões metodológicas do SAREL v2</a:t>
+            </a:r>
+            <a:r>
+              <a:rPr lang="en-US" sz="850" dirty="0" i="0" b="0">
+                <a:solidFill>
+                  <a:srgbClr val="1B2A22"/>
+                </a:solidFill>
+                <a:latin typeface="Calibri" pitchFamily="34" charset="0"/>
+                <a:ea typeface="Calibri" pitchFamily="34" charset="-122"/>
+                <a:cs typeface="Calibri" pitchFamily="34" charset="-120"/>
+              </a:rPr>
+              <a:t>: decisões D01 a D26 e parâmetros P01 a P24. Medianeira: UTFPR, 2026a. Documento eletrônico (DECISOES.md), gerado em 16 out. 2026. Não publicado.</a:t>
+            </a:r>
+          </a:p>
+          <a:p>
+            <a:pPr marL="0" indent="0">
+              <a:spcAft>
+                <a:spcPts val="300"/>
+              </a:spcAft>
+              <a:buNone/>
+            </a:pPr>
+            <a:r>
+              <a:rPr lang="en-US" sz="850" dirty="0" i="0" b="0">
+                <a:solidFill>
+                  <a:srgbClr val="1B2A22"/>
+                </a:solidFill>
+                <a:latin typeface="Calibri" pitchFamily="34" charset="0"/>
+                <a:ea typeface="Calibri" pitchFamily="34" charset="-122"/>
+                <a:cs typeface="Calibri" pitchFamily="34" charset="-120"/>
+              </a:rPr>
+              <a:t>SILVA, L. A. F. da. </a:t>
+            </a:r>
+            <a:endParaRPr lang="en-US" sz="1050" dirty="0"/>
+            <a:r>
+              <a:rPr lang="en-US" sz="850" dirty="0" i="0" b="1">
+                <a:solidFill>
+                  <a:srgbClr val="1B2A22"/>
+                </a:solidFill>
+                <a:latin typeface="Calibri" pitchFamily="34" charset="0"/>
+                <a:ea typeface="Calibri" pitchFamily="34" charset="-122"/>
+                <a:cs typeface="Calibri" pitchFamily="34" charset="-120"/>
+              </a:rPr>
+              <a:t>Verificações metodológicas do SAREL v2</a:t>
+            </a:r>
+            <a:r>
+              <a:rPr lang="en-US" sz="850" dirty="0" i="0" b="0">
+                <a:solidFill>
+                  <a:srgbClr val="1B2A22"/>
+                </a:solidFill>
+                <a:latin typeface="Calibri" pitchFamily="34" charset="0"/>
+                <a:ea typeface="Calibri" pitchFamily="34" charset="-122"/>
+                <a:cs typeface="Calibri" pitchFamily="34" charset="-120"/>
+              </a:rPr>
+              <a:t>: levantamento fundiário e gargalo dos estratos (29 set. 2026); remedição dos candidatos da BP3 (30 set. 2026); cobertura dos voos (27 set. 2026). Medianeira: UTFPR, 2026b. Documentos eletrônicos. Não publicado.</a:t>
+            </a:r>
+          </a:p>
+          <a:p>
+            <a:pPr marL="0" indent="0">
+              <a:spcAft>
+                <a:spcPts val="300"/>
+              </a:spcAft>
+              <a:buNone/>
+            </a:pPr>
+            <a:r>
+              <a:rPr lang="en-US" sz="850" dirty="0" i="0" b="0">
+                <a:solidFill>
+                  <a:srgbClr val="1B2A22"/>
+                </a:solidFill>
+                <a:latin typeface="Calibri" pitchFamily="34" charset="0"/>
+                <a:ea typeface="Calibri" pitchFamily="34" charset="-122"/>
+                <a:cs typeface="Calibri" pitchFamily="34" charset="-120"/>
+              </a:rPr>
+              <a:t>SILVA, L. A. F. da. </a:t>
+            </a:r>
+            <a:endParaRPr lang="en-US" sz="1050" dirty="0"/>
+            <a:r>
+              <a:rPr lang="en-US" sz="850" dirty="0" i="0" b="1">
                 <a:solidFill>
                   <a:srgbClr val="1B2A22"/>
                 </a:solidFill>
@@ -5579,7 +5957,7 @@
               <a:t>SAREL v2</a:t>
             </a:r>
             <a:r>
-              <a:rPr lang="en-US" sz="1050" dirty="0" i="0" b="0">
+              <a:rPr lang="en-US" sz="850" dirty="0" i="0" b="0">
                 <a:solidFill>
                   <a:srgbClr val="1B2A22"/>
                 </a:solidFill>
@@ -5588,6 +5966,132 @@
                 <a:cs typeface="Calibri" pitchFamily="34" charset="-120"/>
               </a:rPr>
               <a:t>: Sistema de Amostragem e Rotulagem para Erosão Laminar. Medianeira: UTFPR, 2026c. Software (versão 2.0.0). Código-fonte não publicado.</a:t>
+            </a:r>
+          </a:p>
+          <a:p>
+            <a:pPr marL="0" indent="0">
+              <a:spcAft>
+                <a:spcPts val="300"/>
+              </a:spcAft>
+              <a:buNone/>
+            </a:pPr>
+            <a:r>
+              <a:rPr lang="en-US" sz="850" dirty="0" i="0" b="0">
+                <a:solidFill>
+                  <a:srgbClr val="1B2A22"/>
+                </a:solidFill>
+                <a:latin typeface="Calibri" pitchFamily="34" charset="0"/>
+                <a:ea typeface="Calibri" pitchFamily="34" charset="-122"/>
+                <a:cs typeface="Calibri" pitchFamily="34" charset="-120"/>
+              </a:rPr>
+              <a:t>WISCHMEIER, W. H.; SMITH, D. D. </a:t>
+            </a:r>
+            <a:endParaRPr lang="en-US" sz="1050" dirty="0"/>
+            <a:r>
+              <a:rPr lang="en-US" sz="850" dirty="0" i="0" b="1">
+                <a:solidFill>
+                  <a:srgbClr val="1B2A22"/>
+                </a:solidFill>
+                <a:latin typeface="Calibri" pitchFamily="34" charset="0"/>
+                <a:ea typeface="Calibri" pitchFamily="34" charset="-122"/>
+                <a:cs typeface="Calibri" pitchFamily="34" charset="-120"/>
+              </a:rPr>
+              <a:t>Predicting rainfall erosion losses</a:t>
+            </a:r>
+            <a:r>
+              <a:rPr lang="en-US" sz="850" dirty="0" i="0" b="0">
+                <a:solidFill>
+                  <a:srgbClr val="1B2A22"/>
+                </a:solidFill>
+                <a:latin typeface="Calibri" pitchFamily="34" charset="0"/>
+                <a:ea typeface="Calibri" pitchFamily="34" charset="-122"/>
+                <a:cs typeface="Calibri" pitchFamily="34" charset="-120"/>
+              </a:rPr>
+              <a:t>: a guide to conservation planning. [S. l.]: U.S. Department of Agriculture, Science and Education Administration, 1978. (Agriculture Handbook, 537).</a:t>
+            </a:r>
+          </a:p>
+          <a:p>
+            <a:pPr marL="0" indent="0">
+              <a:spcAft>
+                <a:spcPts val="300"/>
+              </a:spcAft>
+              <a:buNone/>
+            </a:pPr>
+            <a:r>
+              <a:rPr lang="en-US" sz="850" dirty="0" i="0" b="0">
+                <a:solidFill>
+                  <a:srgbClr val="1B2A22"/>
+                </a:solidFill>
+                <a:latin typeface="Calibri" pitchFamily="34" charset="0"/>
+                <a:ea typeface="Calibri" pitchFamily="34" charset="-122"/>
+                <a:cs typeface="Calibri" pitchFamily="34" charset="-120"/>
+              </a:rPr>
+              <a:t>ZANAGA, D. et al. </a:t>
+            </a:r>
+            <a:endParaRPr lang="en-US" sz="1050" dirty="0"/>
+            <a:r>
+              <a:rPr lang="en-US" sz="850" dirty="0" i="0" b="1">
+                <a:solidFill>
+                  <a:srgbClr val="1B2A22"/>
+                </a:solidFill>
+                <a:latin typeface="Calibri" pitchFamily="34" charset="0"/>
+                <a:ea typeface="Calibri" pitchFamily="34" charset="-122"/>
+                <a:cs typeface="Calibri" pitchFamily="34" charset="-120"/>
+              </a:rPr>
+              <a:t>ESA WorldCover 10 m 2020 v100</a:t>
+            </a:r>
+            <a:r>
+              <a:rPr lang="en-US" sz="850" dirty="0" i="0" b="0">
+                <a:solidFill>
+                  <a:srgbClr val="1B2A22"/>
+                </a:solidFill>
+                <a:latin typeface="Calibri" pitchFamily="34" charset="0"/>
+                <a:ea typeface="Calibri" pitchFamily="34" charset="-122"/>
+                <a:cs typeface="Calibri" pitchFamily="34" charset="-120"/>
+              </a:rPr>
+              <a:t>. [S. l.]: Zenodo, 2021. DOI 10.5281/zenodo.5571936.</a:t>
+            </a:r>
+          </a:p>
+          <a:p>
+            <a:pPr marL="0" indent="0">
+              <a:spcAft>
+                <a:spcPts val="300"/>
+              </a:spcAft>
+              <a:buNone/>
+            </a:pPr>
+            <a:r>
+              <a:rPr lang="en-US" sz="850" dirty="0" i="0" b="0">
+                <a:solidFill>
+                  <a:srgbClr val="1B2A22"/>
+                </a:solidFill>
+                <a:latin typeface="Calibri" pitchFamily="34" charset="0"/>
+                <a:ea typeface="Calibri" pitchFamily="34" charset="-122"/>
+                <a:cs typeface="Calibri" pitchFamily="34" charset="-120"/>
+              </a:rPr>
+              <a:t>ZANAGA, D. et al. </a:t>
+            </a:r>
+            <a:endParaRPr lang="en-US" sz="1050" dirty="0"/>
+            <a:r>
+              <a:rPr lang="en-US" sz="850" dirty="0" i="0" b="1">
+                <a:solidFill>
+                  <a:srgbClr val="1B2A22"/>
+                </a:solidFill>
+                <a:latin typeface="Calibri" pitchFamily="34" charset="0"/>
+                <a:ea typeface="Calibri" pitchFamily="34" charset="-122"/>
+                <a:cs typeface="Calibri" pitchFamily="34" charset="-120"/>
+              </a:rPr>
+              <a:t>ESA WorldCover 10 m 2021 v200</a:t>
+            </a:r>
+            <a:r>
+              <a:rPr lang="en-US" sz="850" dirty="0" i="0" b="0">
+                <a:solidFill>
+                  <a:srgbClr val="1B2A22"/>
+                </a:solidFill>
+                <a:latin typeface="Calibri" pitchFamily="34" charset="0"/>
+                <a:ea typeface="Calibri" pitchFamily="34" charset="-122"/>
+                <a:cs typeface="Calibri" pitchFamily="34" charset="-120"/>
+              </a:rPr>
+              <a:t>. [S. l.]: Zenodo, 2022. DOI 10.5281/zenodo.7254221.</a:t>
             </a:r>
           </a:p>
         </p:txBody>
@@ -5600,8 +6104,8 @@
         </p:nvSpPr>
         <p:spPr>
           <a:xfrm>
-            <a:off x="457200" y="4754880"/>
-            <a:ext cx="7863840" cy="292608"/>
+            <a:off x="457200" y="4736592"/>
+            <a:ext cx="7863840" cy="365760"/>
           </a:xfrm>
           <a:prstGeom prst="rect">
             <a:avLst/>
@@ -5617,7 +6121,7 @@
               <a:buNone/>
             </a:pPr>
             <a:r>
-              <a:rPr lang="en-US" sz="900" i="1" dirty="0">
+              <a:rPr lang="en-US" sz="850" i="1" dirty="0">
                 <a:solidFill>
                   <a:srgbClr val="52605A"/>
                 </a:solidFill>
@@ -5625,7 +6129,7 @@
                 <a:ea typeface="Calibri" pitchFamily="34" charset="-122"/>
                 <a:cs typeface="Calibri" pitchFamily="34" charset="-120"/>
               </a:rPr>
-              <a:t>Obras externas conferidas contra a fonte primária (PDF arquivado no projeto). Documentos internos do SAREL: não publicados. Citações no texto conforme a ABNT NBR 10520; referências conforme a NBR 6023.</a:t>
+              <a:t>Obras externas conferidas (PDF arquivado no projeto ou registro bibliográfico consultado em 19/10/2026). Documentos internos do SAREL não publicados. Citações: NBR 10520; referências: NBR 6023.</a:t>
             </a:r>
             <a:endParaRPr lang="en-US" sz="1000" dirty="0"/>
           </a:p>
@@ -6301,8 +6805,8 @@
         </p:nvSpPr>
         <p:spPr>
           <a:xfrm>
-            <a:off x="457200" y="4727448"/>
-            <a:ext cx="7863840" cy="365760"/>
+            <a:off x="457200" y="4709160"/>
+            <a:ext cx="7863840" cy="384048"/>
           </a:xfrm>
           <a:prstGeom prst="rect">
             <a:avLst/>
@@ -7151,7 +7655,7 @@
                 <a:ea typeface="Calibri" pitchFamily="34" charset="-122"/>
                 <a:cs typeface="Calibri" pitchFamily="34" charset="-120"/>
               </a:rPr>
-              <a:t>C# (Windows Forms) no instalador  ·  PowerShell e Batch nos lançadores  ·  JavaScript (Node) em scripts de apoio  ·  SQL (SQLite) para a base fundiária local  ·  Google Earth Engine (API JavaScript/REST) para Sentinel-2</a:t>
+              <a:t>C# (Windows Forms) no instalador  ·  PowerShell e Batch nos lançadores  ·  JavaScript (Node) em scripts de apoio  ·  SQL (SQLite) para a base fundiária local  ·  Google Earth Engine (GORELICK et al., 2017; API JavaScript/REST) para Sentinel-2</a:t>
             </a:r>
             <a:endParaRPr lang="en-US" sz="1100" dirty="0"/>
           </a:p>
@@ -7298,8 +7802,8 @@
         </p:nvSpPr>
         <p:spPr>
           <a:xfrm>
-            <a:off x="457200" y="4727448"/>
-            <a:ext cx="7863840" cy="365760"/>
+            <a:off x="457200" y="4709160"/>
+            <a:ext cx="7863840" cy="384048"/>
           </a:xfrm>
           <a:prstGeom prst="rect">
             <a:avLst/>
@@ -7323,7 +7827,7 @@
                 <a:ea typeface="Calibri" pitchFamily="34" charset="-122"/>
                 <a:cs typeface="Calibri" pitchFamily="34" charset="-120"/>
               </a:rPr>
-              <a:t>Fonte: código-fonte do SAREL v2 (SILVA, 2026c); contagem de linhas sobre o branch de desenvolvimento em 19/10/2026.</a:t>
+              <a:t>Fontes: código-fonte do SAREL v2 (SILVA, 2026c), contagem de linhas em 19/10/2026; Google Earth Engine: Gorelick et al. (2017).</a:t>
             </a:r>
             <a:endParaRPr lang="en-US" sz="1000" dirty="0"/>
           </a:p>
@@ -7565,7 +8069,7 @@
                 <a:ea typeface="Calibri" pitchFamily="34" charset="-122"/>
                 <a:cs typeface="Calibri" pitchFamily="34" charset="-120"/>
               </a:rPr>
-              <a:t>Elege candidatos a amostra com imagens de satélite (Google Earth Engine)</a:t>
+              <a:t>Elege candidatos a amostra com imagens de satélite (Google Earth Engine; GORELICK et al., 2017)</a:t>
             </a:r>
             <a:endParaRPr lang="en-US" sz="1400" dirty="0"/>
           </a:p>
@@ -7675,8 +8179,8 @@
         </p:nvSpPr>
         <p:spPr>
           <a:xfrm>
-            <a:off x="457200" y="4727448"/>
-            <a:ext cx="7863840" cy="365760"/>
+            <a:off x="457200" y="4709160"/>
+            <a:ext cx="7863840" cy="384048"/>
           </a:xfrm>
           <a:prstGeom prst="rect">
             <a:avLst/>
@@ -7700,7 +8204,7 @@
                 <a:ea typeface="Calibri" pitchFamily="34" charset="-122"/>
                 <a:cs typeface="Calibri" pitchFamily="34" charset="-120"/>
               </a:rPr>
-              <a:t>Fonte: captura de tela do SAREL v2 (SILVA, 2026c).</a:t>
+              <a:t>Fontes: captura de tela do SAREL v2 (SILVA, 2026c); Google Earth Engine: Gorelick et al. (2017).</a:t>
             </a:r>
             <a:endParaRPr lang="en-US" sz="1000" dirty="0"/>
           </a:p>
@@ -7872,7 +8376,7 @@
                         <a:buNone/>
                       </a:pPr>
                       <a:r>
-                        <a:rPr lang="en-US" sz="1200" b="1" dirty="0">
+                        <a:rPr lang="en-US" sz="1100" b="1" dirty="0">
                           <a:solidFill>
                             <a:srgbClr val="FFFFFF"/>
                           </a:solidFill>
@@ -7940,7 +8444,7 @@
                         <a:buNone/>
                       </a:pPr>
                       <a:r>
-                        <a:rPr lang="en-US" sz="1200" b="1" dirty="0">
+                        <a:rPr lang="en-US" sz="1100" b="1" dirty="0">
                           <a:solidFill>
                             <a:srgbClr val="FFFFFF"/>
                           </a:solidFill>
@@ -8008,7 +8512,7 @@
                         <a:buNone/>
                       </a:pPr>
                       <a:r>
-                        <a:rPr lang="en-US" sz="1200" b="1" dirty="0">
+                        <a:rPr lang="en-US" sz="1100" b="1" dirty="0">
                           <a:solidFill>
                             <a:srgbClr val="FFFFFF"/>
                           </a:solidFill>
@@ -8083,7 +8587,7 @@
                         <a:buNone/>
                       </a:pPr>
                       <a:r>
-                        <a:rPr lang="en-US" sz="1200" b="1" dirty="0">
+                        <a:rPr lang="en-US" sz="1100" b="1" dirty="0">
                           <a:solidFill>
                             <a:srgbClr val="2F6B4F"/>
                           </a:solidFill>
@@ -8148,7 +8652,7 @@
                         <a:buNone/>
                       </a:pPr>
                       <a:r>
-                        <a:rPr lang="en-US" sz="1200" dirty="0">
+                        <a:rPr lang="en-US" sz="1100" dirty="0">
                           <a:solidFill>
                             <a:srgbClr val="1B2A22"/>
                           </a:solidFill>
@@ -8156,7 +8660,7 @@
                           <a:ea typeface="Calibri" pitchFamily="34" charset="-122"/>
                           <a:cs typeface="Calibri" pitchFamily="34" charset="-120"/>
                         </a:rPr>
-                        <a:t>Só se amostra onde o método vale: declividade 3 a 20%, lavoura e pastagem (D07).</a:t>
+                        <a:t>Só se amostra onde o método vale: declividade 3 a 20%, lavoura e pastagem (D07; ZANAGA et al., 2021, 2022).</a:t>
                       </a:r>
                       <a:endParaRPr lang="en-US" sz="1200" dirty="0">
                         <a:latin typeface="Calibri" charset="0"/>
@@ -8213,7 +8717,7 @@
                         <a:buNone/>
                       </a:pPr>
                       <a:r>
-                        <a:rPr lang="en-US" sz="1200" dirty="0">
+                        <a:rPr lang="en-US" sz="1100" dirty="0">
                           <a:solidFill>
                             <a:srgbClr val="1B2A22"/>
                           </a:solidFill>
@@ -8285,7 +8789,7 @@
                         <a:buNone/>
                       </a:pPr>
                       <a:r>
-                        <a:rPr lang="en-US" sz="1200" b="1" dirty="0">
+                        <a:rPr lang="en-US" sz="1100" b="1" dirty="0">
                           <a:solidFill>
                             <a:srgbClr val="2F6B4F"/>
                           </a:solidFill>
@@ -8350,7 +8854,7 @@
                         <a:buNone/>
                       </a:pPr>
                       <a:r>
-                        <a:rPr lang="en-US" sz="1200" dirty="0">
+                        <a:rPr lang="en-US" sz="1100" dirty="0">
                           <a:solidFill>
                             <a:srgbClr val="1B2A22"/>
                           </a:solidFill>
@@ -8415,7 +8919,7 @@
                         <a:buNone/>
                       </a:pPr>
                       <a:r>
-                        <a:rPr lang="en-US" sz="1200" dirty="0">
+                        <a:rPr lang="en-US" sz="1100" dirty="0">
                           <a:solidFill>
                             <a:srgbClr val="1B2A22"/>
                           </a:solidFill>
@@ -8487,7 +8991,7 @@
                         <a:buNone/>
                       </a:pPr>
                       <a:r>
-                        <a:rPr lang="en-US" sz="1200" b="1" dirty="0">
+                        <a:rPr lang="en-US" sz="1100" b="1" dirty="0">
                           <a:solidFill>
                             <a:srgbClr val="2F6B4F"/>
                           </a:solidFill>
@@ -8552,7 +9056,7 @@
                         <a:buNone/>
                       </a:pPr>
                       <a:r>
-                        <a:rPr lang="en-US" sz="1200" dirty="0">
+                        <a:rPr lang="en-US" sz="1100" dirty="0">
                           <a:solidFill>
                             <a:srgbClr val="1B2A22"/>
                           </a:solidFill>
@@ -8560,29 +9064,7 @@
                           <a:ea typeface="Calibri" pitchFamily="34" charset="-122"/>
                           <a:cs typeface="Calibri" pitchFamily="34" charset="-120"/>
                         </a:rPr>
-                        <a:t>Declividade × solo nu × </a:t>
-                      </a:r>
-                      <a:r>
-                        <a:rPr lang="en-US" sz="1200" dirty="0" err="1">
-                          <a:solidFill>
-                            <a:srgbClr val="1B2A22"/>
-                          </a:solidFill>
-                          <a:latin typeface="Calibri" pitchFamily="34" charset="0"/>
-                          <a:ea typeface="Calibri" pitchFamily="34" charset="-122"/>
-                          <a:cs typeface="Calibri" pitchFamily="34" charset="-120"/>
-                        </a:rPr>
-                        <a:t>erodibilidade</a:t>
-                      </a:r>
-                      <a:r>
-                        <a:rPr lang="en-US" sz="1200" dirty="0">
-                          <a:solidFill>
-                            <a:srgbClr val="1B2A22"/>
-                          </a:solidFill>
-                          <a:latin typeface="Calibri" pitchFamily="34" charset="0"/>
-                          <a:ea typeface="Calibri" pitchFamily="34" charset="-122"/>
-                          <a:cs typeface="Calibri" pitchFamily="34" charset="-120"/>
-                        </a:rPr>
-                        <a:t>.</a:t>
+                        <a:t>Declividade × solo nu × erodibilidade (COELHO et al., 2024; COCHRAN, 1977).</a:t>
                       </a:r>
                       <a:endParaRPr lang="en-US" sz="1200" dirty="0">
                         <a:latin typeface="Calibri" charset="0"/>
@@ -8639,7 +9121,7 @@
                         <a:buNone/>
                       </a:pPr>
                       <a:r>
-                        <a:rPr lang="en-US" sz="1200" dirty="0">
+                        <a:rPr lang="en-US" sz="1100" dirty="0">
                           <a:solidFill>
                             <a:srgbClr val="1B2A22"/>
                           </a:solidFill>
@@ -8650,7 +9132,7 @@
                         <a:t>Define o que o sorteio </a:t>
                       </a:r>
                       <a:r>
-                        <a:rPr lang="en-US" sz="1200" dirty="0" err="1">
+                        <a:rPr lang="en-US" sz="1100" dirty="0" err="1">
                           <a:solidFill>
                             <a:srgbClr val="1B2A22"/>
                           </a:solidFill>
@@ -8661,7 +9143,7 @@
                         <a:t>precisa</a:t>
                       </a:r>
                       <a:r>
-                        <a:rPr lang="en-US" sz="1200" dirty="0">
+                        <a:rPr lang="en-US" sz="1100" dirty="0">
                           <a:solidFill>
                             <a:srgbClr val="1B2A22"/>
                           </a:solidFill>
@@ -8672,7 +9154,7 @@
                         <a:t> </a:t>
                       </a:r>
                       <a:r>
-                        <a:rPr lang="en-US" sz="1200" dirty="0" err="1">
+                        <a:rPr lang="en-US" sz="1100" dirty="0" err="1">
                           <a:solidFill>
                             <a:srgbClr val="1B2A22"/>
                           </a:solidFill>
@@ -8744,7 +9226,7 @@
                         <a:buNone/>
                       </a:pPr>
                       <a:r>
-                        <a:rPr lang="en-US" sz="1200" b="1" dirty="0">
+                        <a:rPr lang="en-US" sz="1100" b="1" dirty="0">
                           <a:solidFill>
                             <a:srgbClr val="2F6B4F"/>
                           </a:solidFill>
@@ -8809,7 +9291,7 @@
                         <a:buNone/>
                       </a:pPr>
                       <a:r>
-                        <a:rPr lang="en-US" sz="1200" dirty="0">
+                        <a:rPr lang="en-US" sz="1100" dirty="0">
                           <a:solidFill>
                             <a:srgbClr val="1B2A22"/>
                           </a:solidFill>
@@ -8874,7 +9356,7 @@
                         <a:buNone/>
                       </a:pPr>
                       <a:r>
-                        <a:rPr lang="en-US" sz="1200" dirty="0">
+                        <a:rPr lang="en-US" sz="1100" dirty="0">
                           <a:solidFill>
                             <a:srgbClr val="1B2A22"/>
                           </a:solidFill>
@@ -8946,7 +9428,7 @@
                         <a:buNone/>
                       </a:pPr>
                       <a:r>
-                        <a:rPr lang="en-US" sz="1200" b="1" dirty="0">
+                        <a:rPr lang="en-US" sz="1100" b="1" dirty="0">
                           <a:solidFill>
                             <a:srgbClr val="2F6B4F"/>
                           </a:solidFill>
@@ -9011,7 +9493,7 @@
                         <a:buNone/>
                       </a:pPr>
                       <a:r>
-                        <a:rPr lang="en-US" sz="1200" dirty="0">
+                        <a:rPr lang="en-US" sz="1100" dirty="0">
                           <a:solidFill>
                             <a:srgbClr val="1B2A22"/>
                           </a:solidFill>
@@ -9019,29 +9501,7 @@
                           <a:ea typeface="Calibri" pitchFamily="34" charset="-122"/>
                           <a:cs typeface="Calibri" pitchFamily="34" charset="-120"/>
                         </a:rPr>
-                        <a:t>4 por estrato, probabilidade de inclusão </a:t>
-                      </a:r>
-                      <a:r>
-                        <a:rPr lang="en-US" sz="1200" dirty="0" err="1">
-                          <a:solidFill>
-                            <a:srgbClr val="1B2A22"/>
-                          </a:solidFill>
-                          <a:latin typeface="Calibri" pitchFamily="34" charset="0"/>
-                          <a:ea typeface="Calibri" pitchFamily="34" charset="-122"/>
-                          <a:cs typeface="Calibri" pitchFamily="34" charset="-120"/>
-                        </a:rPr>
-                        <a:t>registrada</a:t>
-                      </a:r>
-                      <a:r>
-                        <a:rPr lang="en-US" sz="1200" dirty="0">
-                          <a:solidFill>
-                            <a:srgbClr val="1B2A22"/>
-                          </a:solidFill>
-                          <a:latin typeface="Calibri" pitchFamily="34" charset="0"/>
-                          <a:ea typeface="Calibri" pitchFamily="34" charset="-122"/>
-                          <a:cs typeface="Calibri" pitchFamily="34" charset="-120"/>
-                        </a:rPr>
-                        <a:t> .</a:t>
+                        <a:t>4 por estrato, probabilidade de inclusão registrada (KING; ZENG, 2001).</a:t>
                       </a:r>
                       <a:endParaRPr lang="en-US" sz="1200" dirty="0">
                         <a:latin typeface="Calibri" charset="0"/>
@@ -9098,7 +9558,7 @@
                         <a:buNone/>
                       </a:pPr>
                       <a:r>
-                        <a:rPr lang="en-US" sz="1200" dirty="0">
+                        <a:rPr lang="en-US" sz="1100" dirty="0">
                           <a:solidFill>
                             <a:srgbClr val="1B2A22"/>
                           </a:solidFill>
@@ -9172,8 +9632,8 @@
         </p:nvSpPr>
         <p:spPr>
           <a:xfrm>
-            <a:off x="457200" y="4727448"/>
-            <a:ext cx="7863840" cy="365760"/>
+            <a:off x="457200" y="4663440"/>
+            <a:ext cx="7863840" cy="457200"/>
           </a:xfrm>
           <a:prstGeom prst="rect">
             <a:avLst/>
@@ -9197,7 +9657,7 @@
                 <a:ea typeface="Calibri" pitchFamily="34" charset="-122"/>
                 <a:cs typeface="Calibri" pitchFamily="34" charset="-120"/>
               </a:rPr>
-              <a:t>Cada passo depende do anterior: o sorteio selado e a avaliação única são os dois pontos sem volta. Fontes: SILVA (2026a, D07, P02, D12 e D23).</a:t>
+              <a:t>Cada passo depende do anterior: o sorteio selado e a avaliação única são os dois pontos sem volta. Fontes: SILVA (2026a, D07, P02, D12 e D23); Zanaga et al. (2021, 2022); Cochran (1977); King e Zeng (2001); Coelho et al. (2024).</a:t>
             </a:r>
             <a:endParaRPr lang="en-US" sz="1000" dirty="0"/>
           </a:p>
@@ -9855,51 +10315,7 @@
                           <a:ea typeface="Calibri" pitchFamily="34" charset="-122"/>
                           <a:cs typeface="Calibri" pitchFamily="34" charset="-120"/>
                         </a:rPr>
-                        <a:t>Intérprete sem ver estrato nem papel; rótulo </a:t>
-                      </a:r>
-                      <a:r>
-                        <a:rPr lang="en-US" sz="1200" dirty="0" err="1">
-                          <a:solidFill>
-                            <a:srgbClr val="1B2A22"/>
-                          </a:solidFill>
-                          <a:latin typeface="Calibri" pitchFamily="34" charset="0"/>
-                          <a:ea typeface="Calibri" pitchFamily="34" charset="-122"/>
-                          <a:cs typeface="Calibri" pitchFamily="34" charset="-120"/>
-                        </a:rPr>
-                        <a:t>por</a:t>
-                      </a:r>
-                      <a:r>
-                        <a:rPr lang="en-US" sz="1200" dirty="0">
-                          <a:solidFill>
-                            <a:srgbClr val="1B2A22"/>
-                          </a:solidFill>
-                          <a:latin typeface="Calibri" pitchFamily="34" charset="0"/>
-                          <a:ea typeface="Calibri" pitchFamily="34" charset="-122"/>
-                          <a:cs typeface="Calibri" pitchFamily="34" charset="-120"/>
-                        </a:rPr>
-                        <a:t> </a:t>
-                      </a:r>
-                      <a:r>
-                        <a:rPr lang="en-US" sz="1200" dirty="0" err="1">
-                          <a:solidFill>
-                            <a:srgbClr val="1B2A22"/>
-                          </a:solidFill>
-                          <a:latin typeface="Calibri" pitchFamily="34" charset="0"/>
-                          <a:ea typeface="Calibri" pitchFamily="34" charset="-122"/>
-                          <a:cs typeface="Calibri" pitchFamily="34" charset="-120"/>
-                        </a:rPr>
-                        <a:t>fração</a:t>
-                      </a:r>
-                      <a:r>
-                        <a:rPr lang="en-US" sz="1200" dirty="0">
-                          <a:solidFill>
-                            <a:srgbClr val="1B2A22"/>
-                          </a:solidFill>
-                          <a:latin typeface="Calibri" pitchFamily="34" charset="0"/>
-                          <a:ea typeface="Calibri" pitchFamily="34" charset="-122"/>
-                          <a:cs typeface="Calibri" pitchFamily="34" charset="-120"/>
-                        </a:rPr>
-                        <a:t>.</a:t>
+                        <a:t>Intérprete sem ver estrato nem papel; rótulo por fração (ALTMAN; ROYSTON, 2006).</a:t>
                       </a:r>
                       <a:endParaRPr lang="en-US" sz="1200" dirty="0">
                         <a:latin typeface="Calibri" charset="0"/>
@@ -10101,51 +10517,7 @@
                           <a:ea typeface="Calibri" pitchFamily="34" charset="-122"/>
                           <a:cs typeface="Calibri" pitchFamily="34" charset="-120"/>
                         </a:rPr>
-                        <a:t>60 a 80 </a:t>
-                      </a:r>
-                      <a:r>
-                        <a:rPr lang="en-US" sz="1200" dirty="0" err="1">
-                          <a:solidFill>
-                            <a:srgbClr val="1B2A22"/>
-                          </a:solidFill>
-                          <a:latin typeface="Calibri" pitchFamily="34" charset="0"/>
-                          <a:ea typeface="Calibri" pitchFamily="34" charset="-122"/>
-                          <a:cs typeface="Calibri" pitchFamily="34" charset="-120"/>
-                        </a:rPr>
-                        <a:t>pontos</a:t>
-                      </a:r>
-                      <a:r>
-                        <a:rPr lang="en-US" sz="1200" dirty="0">
-                          <a:solidFill>
-                            <a:srgbClr val="1B2A22"/>
-                          </a:solidFill>
-                          <a:latin typeface="Calibri" pitchFamily="34" charset="0"/>
-                          <a:ea typeface="Calibri" pitchFamily="34" charset="-122"/>
-                          <a:cs typeface="Calibri" pitchFamily="34" charset="-120"/>
-                        </a:rPr>
-                        <a:t> fora dos polígonos, coletados no SAREL </a:t>
-                      </a:r>
-                      <a:r>
-                        <a:rPr lang="en-US" sz="1200" dirty="0" err="1">
-                          <a:solidFill>
-                            <a:srgbClr val="1B2A22"/>
-                          </a:solidFill>
-                          <a:latin typeface="Calibri" pitchFamily="34" charset="0"/>
-                          <a:ea typeface="Calibri" pitchFamily="34" charset="-122"/>
-                          <a:cs typeface="Calibri" pitchFamily="34" charset="-120"/>
-                        </a:rPr>
-                        <a:t>Coletor</a:t>
-                      </a:r>
-                      <a:r>
-                        <a:rPr lang="en-US" sz="1200" dirty="0">
-                          <a:solidFill>
-                            <a:srgbClr val="1B2A22"/>
-                          </a:solidFill>
-                          <a:latin typeface="Calibri" pitchFamily="34" charset="0"/>
-                          <a:ea typeface="Calibri" pitchFamily="34" charset="-122"/>
-                          <a:cs typeface="Calibri" pitchFamily="34" charset="-120"/>
-                        </a:rPr>
-                        <a:t>.</a:t>
+                        <a:t>60 a 80 pontos fora dos polígonos, coletados no SAREL Coletor (OLOFSSON et al., 2014).</a:t>
                       </a:r>
                       <a:endParaRPr lang="en-US" sz="1200" dirty="0">
                         <a:latin typeface="Calibri" charset="0"/>
@@ -10264,344 +10636,6 @@
                   </a:ext>
                 </a:extLst>
               </a:tr>
-              <a:tr h="502920">
-                <a:tc>
-                  <a:txBody>
-                    <a:bodyPr/>
-                    <a:lstStyle/>
-                    <a:p>
-                      <a:pPr marL="0" indent="0">
-                        <a:buNone/>
-                      </a:pPr>
-                      <a:endParaRPr lang="en-US" sz="1200" dirty="0">
-                        <a:latin typeface="Calibri" charset="0"/>
-                        <a:ea typeface="Calibri" charset="0"/>
-                        <a:cs typeface="Calibri" charset="0"/>
-                      </a:endParaRPr>
-                    </a:p>
-                  </a:txBody>
-                  <a:tcPr marL="73152" marR="73152" marT="36576" marB="36576" anchor="ctr">
-                    <a:lnL w="9525" cap="flat" cmpd="sng" algn="ctr">
-                      <a:solidFill>
-                        <a:srgbClr val="C9D4CC"/>
-                      </a:solidFill>
-                      <a:prstDash val="solid"/>
-                      <a:round/>
-                      <a:headEnd type="none" w="med" len="med"/>
-                      <a:tailEnd type="none" w="med" len="med"/>
-                    </a:lnL>
-                    <a:lnR w="9525" cap="flat" cmpd="sng" algn="ctr">
-                      <a:solidFill>
-                        <a:srgbClr val="C9D4CC"/>
-                      </a:solidFill>
-                      <a:prstDash val="solid"/>
-                      <a:round/>
-                      <a:headEnd type="none" w="med" len="med"/>
-                      <a:tailEnd type="none" w="med" len="med"/>
-                    </a:lnR>
-                    <a:lnT w="9525" cap="flat" cmpd="sng" algn="ctr">
-                      <a:solidFill>
-                        <a:srgbClr val="C9D4CC"/>
-                      </a:solidFill>
-                      <a:prstDash val="solid"/>
-                      <a:round/>
-                      <a:headEnd type="none" w="med" len="med"/>
-                      <a:tailEnd type="none" w="med" len="med"/>
-                    </a:lnT>
-                    <a:lnB w="9525" cap="flat" cmpd="sng" algn="ctr">
-                      <a:solidFill>
-                        <a:srgbClr val="C9D4CC"/>
-                      </a:solidFill>
-                      <a:prstDash val="solid"/>
-                      <a:round/>
-                      <a:headEnd type="none" w="med" len="med"/>
-                      <a:tailEnd type="none" w="med" len="med"/>
-                    </a:lnB>
-                  </a:tcPr>
-                </a:tc>
-                <a:tc>
-                  <a:txBody>
-                    <a:bodyPr/>
-                    <a:lstStyle/>
-                    <a:p>
-                      <a:pPr marL="0" indent="0">
-                        <a:buNone/>
-                      </a:pPr>
-                      <a:endParaRPr lang="en-US" sz="1200" dirty="0">
-                        <a:latin typeface="Calibri" charset="0"/>
-                        <a:ea typeface="Calibri" charset="0"/>
-                        <a:cs typeface="Calibri" charset="0"/>
-                      </a:endParaRPr>
-                    </a:p>
-                  </a:txBody>
-                  <a:tcPr marL="73152" marR="73152" marT="36576" marB="36576" anchor="ctr">
-                    <a:lnL w="9525" cap="flat" cmpd="sng" algn="ctr">
-                      <a:solidFill>
-                        <a:srgbClr val="C9D4CC"/>
-                      </a:solidFill>
-                      <a:prstDash val="solid"/>
-                      <a:round/>
-                      <a:headEnd type="none" w="med" len="med"/>
-                      <a:tailEnd type="none" w="med" len="med"/>
-                    </a:lnL>
-                    <a:lnR w="9525" cap="flat" cmpd="sng" algn="ctr">
-                      <a:solidFill>
-                        <a:srgbClr val="C9D4CC"/>
-                      </a:solidFill>
-                      <a:prstDash val="solid"/>
-                      <a:round/>
-                      <a:headEnd type="none" w="med" len="med"/>
-                      <a:tailEnd type="none" w="med" len="med"/>
-                    </a:lnR>
-                    <a:lnT w="9525" cap="flat" cmpd="sng" algn="ctr">
-                      <a:solidFill>
-                        <a:srgbClr val="C9D4CC"/>
-                      </a:solidFill>
-                      <a:prstDash val="solid"/>
-                      <a:round/>
-                      <a:headEnd type="none" w="med" len="med"/>
-                      <a:tailEnd type="none" w="med" len="med"/>
-                    </a:lnT>
-                    <a:lnB w="9525" cap="flat" cmpd="sng" algn="ctr">
-                      <a:solidFill>
-                        <a:srgbClr val="C9D4CC"/>
-                      </a:solidFill>
-                      <a:prstDash val="solid"/>
-                      <a:round/>
-                      <a:headEnd type="none" w="med" len="med"/>
-                      <a:tailEnd type="none" w="med" len="med"/>
-                    </a:lnB>
-                  </a:tcPr>
-                </a:tc>
-                <a:tc>
-                  <a:txBody>
-                    <a:bodyPr/>
-                    <a:lstStyle/>
-                    <a:p>
-                      <a:pPr marL="0" indent="0">
-                        <a:buNone/>
-                      </a:pPr>
-                      <a:endParaRPr lang="en-US" sz="1200" dirty="0">
-                        <a:latin typeface="Calibri" charset="0"/>
-                        <a:ea typeface="Calibri" charset="0"/>
-                        <a:cs typeface="Calibri" charset="0"/>
-                      </a:endParaRPr>
-                    </a:p>
-                  </a:txBody>
-                  <a:tcPr marL="73152" marR="73152" marT="36576" marB="36576" anchor="ctr">
-                    <a:lnL w="9525" cap="flat" cmpd="sng" algn="ctr">
-                      <a:solidFill>
-                        <a:srgbClr val="C9D4CC"/>
-                      </a:solidFill>
-                      <a:prstDash val="solid"/>
-                      <a:round/>
-                      <a:headEnd type="none" w="med" len="med"/>
-                      <a:tailEnd type="none" w="med" len="med"/>
-                    </a:lnL>
-                    <a:lnR w="9525" cap="flat" cmpd="sng" algn="ctr">
-                      <a:solidFill>
-                        <a:srgbClr val="C9D4CC"/>
-                      </a:solidFill>
-                      <a:prstDash val="solid"/>
-                      <a:round/>
-                      <a:headEnd type="none" w="med" len="med"/>
-                      <a:tailEnd type="none" w="med" len="med"/>
-                    </a:lnR>
-                    <a:lnT w="9525" cap="flat" cmpd="sng" algn="ctr">
-                      <a:solidFill>
-                        <a:srgbClr val="C9D4CC"/>
-                      </a:solidFill>
-                      <a:prstDash val="solid"/>
-                      <a:round/>
-                      <a:headEnd type="none" w="med" len="med"/>
-                      <a:tailEnd type="none" w="med" len="med"/>
-                    </a:lnT>
-                    <a:lnB w="9525" cap="flat" cmpd="sng" algn="ctr">
-                      <a:solidFill>
-                        <a:srgbClr val="C9D4CC"/>
-                      </a:solidFill>
-                      <a:prstDash val="solid"/>
-                      <a:round/>
-                      <a:headEnd type="none" w="med" len="med"/>
-                      <a:tailEnd type="none" w="med" len="med"/>
-                    </a:lnB>
-                  </a:tcPr>
-                </a:tc>
-                <a:extLst>
-                  <a:ext uri="{0D108BD9-81ED-4DB2-BD59-A6C34878D82A}">
-                    <a16:rowId xmlns:a16="http://schemas.microsoft.com/office/drawing/2014/main" val="10004"/>
-                  </a:ext>
-                </a:extLst>
-              </a:tr>
-              <a:tr h="502920">
-                <a:tc>
-                  <a:txBody>
-                    <a:bodyPr/>
-                    <a:lstStyle/>
-                    <a:p>
-                      <a:pPr marL="0" indent="0">
-                        <a:buNone/>
-                      </a:pPr>
-                      <a:endParaRPr lang="en-US" sz="1200" dirty="0">
-                        <a:latin typeface="Calibri" charset="0"/>
-                        <a:ea typeface="Calibri" charset="0"/>
-                        <a:cs typeface="Calibri" charset="0"/>
-                      </a:endParaRPr>
-                    </a:p>
-                  </a:txBody>
-                  <a:tcPr marL="73152" marR="73152" marT="36576" marB="36576" anchor="ctr">
-                    <a:lnL w="9525" cap="flat" cmpd="sng" algn="ctr">
-                      <a:solidFill>
-                        <a:srgbClr val="C9D4CC"/>
-                      </a:solidFill>
-                      <a:prstDash val="solid"/>
-                      <a:round/>
-                      <a:headEnd type="none" w="med" len="med"/>
-                      <a:tailEnd type="none" w="med" len="med"/>
-                    </a:lnL>
-                    <a:lnR w="9525" cap="flat" cmpd="sng" algn="ctr">
-                      <a:solidFill>
-                        <a:srgbClr val="C9D4CC"/>
-                      </a:solidFill>
-                      <a:prstDash val="solid"/>
-                      <a:round/>
-                      <a:headEnd type="none" w="med" len="med"/>
-                      <a:tailEnd type="none" w="med" len="med"/>
-                    </a:lnR>
-                    <a:lnT w="9525" cap="flat" cmpd="sng" algn="ctr">
-                      <a:solidFill>
-                        <a:srgbClr val="C9D4CC"/>
-                      </a:solidFill>
-                      <a:prstDash val="solid"/>
-                      <a:round/>
-                      <a:headEnd type="none" w="med" len="med"/>
-                      <a:tailEnd type="none" w="med" len="med"/>
-                    </a:lnT>
-                    <a:lnB w="9525" cap="flat" cmpd="sng" algn="ctr">
-                      <a:solidFill>
-                        <a:srgbClr val="C9D4CC"/>
-                      </a:solidFill>
-                      <a:prstDash val="solid"/>
-                      <a:round/>
-                      <a:headEnd type="none" w="med" len="med"/>
-                      <a:tailEnd type="none" w="med" len="med"/>
-                    </a:lnB>
-                  </a:tcPr>
-                </a:tc>
-                <a:tc>
-                  <a:txBody>
-                    <a:bodyPr/>
-                    <a:lstStyle/>
-                    <a:p>
-                      <a:pPr marL="0" indent="0">
-                        <a:buNone/>
-                      </a:pPr>
-                      <a:endParaRPr lang="en-US" sz="1200" dirty="0">
-                        <a:latin typeface="Calibri" charset="0"/>
-                        <a:ea typeface="Calibri" charset="0"/>
-                        <a:cs typeface="Calibri" charset="0"/>
-                      </a:endParaRPr>
-                    </a:p>
-                  </a:txBody>
-                  <a:tcPr marL="73152" marR="73152" marT="36576" marB="36576" anchor="ctr">
-                    <a:lnL w="9525" cap="flat" cmpd="sng" algn="ctr">
-                      <a:solidFill>
-                        <a:srgbClr val="C9D4CC"/>
-                      </a:solidFill>
-                      <a:prstDash val="solid"/>
-                      <a:round/>
-                      <a:headEnd type="none" w="med" len="med"/>
-                      <a:tailEnd type="none" w="med" len="med"/>
-                    </a:lnL>
-                    <a:lnR w="9525" cap="flat" cmpd="sng" algn="ctr">
-                      <a:solidFill>
-                        <a:srgbClr val="C9D4CC"/>
-                      </a:solidFill>
-                      <a:prstDash val="solid"/>
-                      <a:round/>
-                      <a:headEnd type="none" w="med" len="med"/>
-                      <a:tailEnd type="none" w="med" len="med"/>
-                    </a:lnR>
-                    <a:lnT w="9525" cap="flat" cmpd="sng" algn="ctr">
-                      <a:solidFill>
-                        <a:srgbClr val="C9D4CC"/>
-                      </a:solidFill>
-                      <a:prstDash val="solid"/>
-                      <a:round/>
-                      <a:headEnd type="none" w="med" len="med"/>
-                      <a:tailEnd type="none" w="med" len="med"/>
-                    </a:lnT>
-                    <a:lnB w="9525" cap="flat" cmpd="sng" algn="ctr">
-                      <a:solidFill>
-                        <a:srgbClr val="C9D4CC"/>
-                      </a:solidFill>
-                      <a:prstDash val="solid"/>
-                      <a:round/>
-                      <a:headEnd type="none" w="med" len="med"/>
-                      <a:tailEnd type="none" w="med" len="med"/>
-                    </a:lnB>
-                  </a:tcPr>
-                </a:tc>
-                <a:tc>
-                  <a:txBody>
-                    <a:bodyPr/>
-                    <a:lstStyle/>
-                    <a:p>
-                      <a:pPr marL="0" indent="0">
-                        <a:buNone/>
-                      </a:pPr>
-                      <a:endParaRPr lang="en-US" sz="1200" dirty="0">
-                        <a:latin typeface="Calibri" charset="0"/>
-                        <a:ea typeface="Calibri" charset="0"/>
-                        <a:cs typeface="Calibri" charset="0"/>
-                      </a:endParaRPr>
-                    </a:p>
-                  </a:txBody>
-                  <a:tcPr marL="73152" marR="73152" marT="36576" marB="36576" anchor="ctr">
-                    <a:lnL w="9525" cap="flat" cmpd="sng" algn="ctr">
-                      <a:solidFill>
-                        <a:srgbClr val="C9D4CC"/>
-                      </a:solidFill>
-                      <a:prstDash val="solid"/>
-                      <a:round/>
-                      <a:headEnd type="none" w="med" len="med"/>
-                      <a:tailEnd type="none" w="med" len="med"/>
-                    </a:lnL>
-                    <a:lnR w="9525" cap="flat" cmpd="sng" algn="ctr">
-                      <a:solidFill>
-                        <a:srgbClr val="C9D4CC"/>
-                      </a:solidFill>
-                      <a:prstDash val="solid"/>
-                      <a:round/>
-                      <a:headEnd type="none" w="med" len="med"/>
-                      <a:tailEnd type="none" w="med" len="med"/>
-                    </a:lnR>
-                    <a:lnT w="9525" cap="flat" cmpd="sng" algn="ctr">
-                      <a:solidFill>
-                        <a:srgbClr val="C9D4CC"/>
-                      </a:solidFill>
-                      <a:prstDash val="solid"/>
-                      <a:round/>
-                      <a:headEnd type="none" w="med" len="med"/>
-                      <a:tailEnd type="none" w="med" len="med"/>
-                    </a:lnT>
-                    <a:lnB w="9525" cap="flat" cmpd="sng" algn="ctr">
-                      <a:solidFill>
-                        <a:srgbClr val="C9D4CC"/>
-                      </a:solidFill>
-                      <a:prstDash val="solid"/>
-                      <a:round/>
-                      <a:headEnd type="none" w="med" len="med"/>
-                      <a:tailEnd type="none" w="med" len="med"/>
-                    </a:lnB>
-                  </a:tcPr>
-                </a:tc>
-                <a:extLst>
-                  <a:ext uri="{0D108BD9-81ED-4DB2-BD59-A6C34878D82A}">
-                    <a16:rowId xmlns:a16="http://schemas.microsoft.com/office/drawing/2014/main" val="10005"/>
-                  </a:ext>
-                </a:extLst>
-              </a:tr>
             </a:tbl>
           </a:graphicData>
         </a:graphic>
@@ -10614,8 +10648,8 @@
         </p:nvSpPr>
         <p:spPr>
           <a:xfrm>
-            <a:off x="457200" y="4727448"/>
-            <a:ext cx="7863840" cy="365760"/>
+            <a:off x="457200" y="4663440"/>
+            <a:ext cx="7863840" cy="457200"/>
           </a:xfrm>
           <a:prstGeom prst="rect">
             <a:avLst/>
@@ -10639,7 +10673,7 @@
                 <a:ea typeface="Calibri" pitchFamily="34" charset="-122"/>
                 <a:cs typeface="Calibri" pitchFamily="34" charset="-120"/>
               </a:rPr>
-              <a:t>Cada passo depende do anterior: o sorteio selado e a avaliação única são os dois pontos sem volta. Fontes: SILVA (2026a, D16, D23, D25 e D26).</a:t>
+              <a:t>Cada passo depende do anterior: o sorteio selado e a avaliação única são os dois pontos sem volta. Fontes: SILVA (2026a, D16, D23, D25 e D26); Altman e Royston (2006); Olofsson et al. (2014); pré-registro da avaliação: Nosek et al. (2018).</a:t>
             </a:r>
             <a:endParaRPr lang="en-US" sz="1000" dirty="0"/>
           </a:p>
@@ -11342,7 +11376,7 @@
                 <a:ea typeface="Calibri" pitchFamily="34" charset="-122"/>
                 <a:cs typeface="Calibri" pitchFamily="34" charset="-120"/>
               </a:rPr>
-              <a:t>Por que estratificar: sem isso o acaso concentraria a amostra nas combinações comuns e deixaria vazios os estratos raros, de maior interesse</a:t>
+              <a:t>Por que estratificar: sem isso o acaso concentraria a amostra nas combinações comuns e deixaria vazios os estratos raros, de maior interesse (COCHRAN, 1977)</a:t>
             </a:r>
             <a:endParaRPr lang="en-US" sz="1050" dirty="0"/>
           </a:p>
@@ -11429,7 +11463,7 @@
                 <a:ea typeface="Cambria" pitchFamily="34" charset="-122"/>
                 <a:cs typeface="Cambria" pitchFamily="34" charset="-120"/>
               </a:rPr>
-              <a:t>Onde entra a série temporal (Sentinel-2, 2016–2026)</a:t>
+              <a:t>Onde entra a série temporal (Sentinel-2, 2016–2026; DRUSCH et al., 2012)</a:t>
             </a:r>
             <a:endParaRPr lang="en-US" sz="1150" dirty="0"/>
           </a:p>
@@ -11482,8 +11516,8 @@
         </p:nvSpPr>
         <p:spPr>
           <a:xfrm>
-            <a:off x="457200" y="4727448"/>
-            <a:ext cx="7863840" cy="365760"/>
+            <a:off x="457200" y="4709160"/>
+            <a:ext cx="7863840" cy="384048"/>
           </a:xfrm>
           <a:prstGeom prst="rect">
             <a:avLst/>
@@ -11507,7 +11541,7 @@
                 <a:ea typeface="Calibri" pitchFamily="34" charset="-122"/>
                 <a:cs typeface="Calibri" pitchFamily="34" charset="-120"/>
               </a:rPr>
-              <a:t>Fontes: COELHO et al. (2024); SILVA (2026a, D05, D09, D10, D11 e D12).</a:t>
+              <a:t>Fontes: COELHO et al. (2024); COCHRAN (1977); DRUSCH et al. (2012); SILVA (2026a, D05, D09, D10, D11 e D12).</a:t>
             </a:r>
             <a:endParaRPr lang="en-US" sz="1000" dirty="0"/>
           </a:p>
@@ -11797,8 +11831,8 @@
         </p:nvSpPr>
         <p:spPr>
           <a:xfrm>
-            <a:off x="457200" y="4727448"/>
-            <a:ext cx="7863840" cy="365760"/>
+            <a:off x="457200" y="4709160"/>
+            <a:ext cx="7863840" cy="384048"/>
           </a:xfrm>
           <a:prstGeom prst="rect">
             <a:avLst/>
@@ -12441,7 +12475,7 @@
                 <a:ea typeface="Calibri" pitchFamily="34" charset="-122"/>
                 <a:cs typeface="Calibri" pitchFamily="34" charset="-120"/>
               </a:rPr>
-              <a:t>Por que 72: 18 estratos × 4 polígonos (2 treino + 2 teste); a área total, cerca de 361 ha, é o que o custo de voo suporta e rende cerca de 1.845 unidades independentes (D24)</a:t>
+              <a:t>Por que 72: 18 estratos × 4 polígonos (2 treino + 2 teste); a área total, cerca de 361 ha, é o que o custo de voo suporta e rende cerca de 1.845 unidades independentes (D24; PLOEG; AUSTIN; STEYERBERG, 2014)</a:t>
             </a:r>
             <a:endParaRPr lang="en-US" sz="1000" dirty="0"/>
           </a:p>
@@ -12476,8 +12510,8 @@
         </p:nvSpPr>
         <p:spPr>
           <a:xfrm>
-            <a:off x="457200" y="4727448"/>
-            <a:ext cx="7863840" cy="365760"/>
+            <a:off x="457200" y="4709160"/>
+            <a:ext cx="7863840" cy="384048"/>
           </a:xfrm>
           <a:prstGeom prst="rect">
             <a:avLst/>
@@ -12501,7 +12535,7 @@
                 <a:ea typeface="Calibri" pitchFamily="34" charset="-122"/>
                 <a:cs typeface="Calibri" pitchFamily="34" charset="-120"/>
               </a:rPr>
-              <a:t>Fontes: SILVA (2026a, D16 e D24); plano de voo e cobertura das missões 000 e 009 (SILVA, 2026b).</a:t>
+              <a:t>Fontes: SILVA (2026a, D16 e D24); plano de voo e cobertura das missões 000 e 009 (SILVA, 2026b); Ploeg, Austin e Steyerberg (2014).</a:t>
             </a:r>
             <a:endParaRPr lang="en-US" sz="1000" dirty="0"/>
           </a:p>

</xml_diff>